<commit_message>
C5·U1 PowerPoint v2 (geüpdate kennis): zichtbare grábate-online-kruisverwijzing op de spreek-dia (Ronda 4: opnemen → terugluisteren, chip «Carrusel: preséntate») + cloze-werkwoord-online-verwijzing bij presente. Vier vaardigheden gedekt, print↔HTML-kruisverwijzing §16. 21 dia's docente / 20 alumno, 128 onthullingen, 32 hyperlinks — structureel geverifieerd
</commit_message>
<xml_diff>
--- a/03-build/pptx/C5_U1_alumno.pptx
+++ b/03-build/pptx/C5_U1_alumno.pptx
@@ -10551,7 +10551,25 @@
                 </a:solidFill>
                 <a:latin typeface="Inter"/>
               </a:rPr>
-              <a:t>uit het hoofd, tegen 3 klasgenoten.</a:t>
+              <a:t>uit het hoofd, tegen 3 klasgenoten. </a:t>
+            </a:r>
+            <a:r>
+              <a:rPr sz="1200" b="1" i="0">
+                <a:solidFill>
+                  <a:srgbClr val="157355"/>
+                </a:solidFill>
+                <a:latin typeface="Inter"/>
+              </a:rPr>
+              <a:t>Ronda 4: </a:t>
+            </a:r>
+            <a:r>
+              <a:rPr sz="1200" b="0" i="0">
+                <a:solidFill>
+                  <a:srgbClr val="20242E"/>
+                </a:solidFill>
+                <a:latin typeface="Inter"/>
+              </a:rPr>
+              <a:t>grábate en de digitale pagina → terugluisteren.</a:t>
             </a:r>
           </a:p>
         </p:txBody>
@@ -10559,6 +10577,61 @@
       <p:sp>
         <p:nvSpPr>
           <p:cNvPr id="29" name="Rounded Rectangle 28"/>
+          <p:cNvSpPr/>
+          <p:nvPr/>
+        </p:nvSpPr>
+        <p:spPr>
+          <a:xfrm>
+            <a:off x="457200" y="4251960"/>
+            <a:ext cx="3652113" cy="292608"/>
+          </a:xfrm>
+          <a:prstGeom prst="roundRect">
+            <a:avLst>
+              <a:gd name="adj" fmla="val 50000"/>
+            </a:avLst>
+          </a:prstGeom>
+          <a:solidFill>
+            <a:srgbClr val="E4F4EE"/>
+          </a:solidFill>
+          <a:ln>
+            <a:noFill/>
+          </a:ln>
+          <a:effectLst/>
+        </p:spPr>
+        <p:style>
+          <a:lnRef idx="1">
+            <a:schemeClr val="accent1"/>
+          </a:lnRef>
+          <a:fillRef idx="3">
+            <a:schemeClr val="accent1"/>
+          </a:fillRef>
+          <a:effectRef idx="2">
+            <a:schemeClr val="accent1"/>
+          </a:effectRef>
+          <a:fontRef idx="minor">
+            <a:schemeClr val="lt1"/>
+          </a:fontRef>
+        </p:style>
+        <p:txBody>
+          <a:bodyPr rtlCol="0" anchor="ctr" wrap="none" lIns="88900" rIns="88900" tIns="12700" bIns="12700"/>
+          <a:lstStyle/>
+          <a:p>
+            <a:pPr algn="ctr"/>
+            <a:r>
+              <a:rPr sz="1100" b="1">
+                <a:solidFill>
+                  <a:srgbClr val="157355"/>
+                </a:solidFill>
+                <a:latin typeface="Inter"/>
+              </a:rPr>
+              <a:t>🎙️ Grábate online · «Carrusel: preséntate»</a:t>
+            </a:r>
+          </a:p>
+        </p:txBody>
+      </p:sp>
+      <p:sp>
+        <p:nvSpPr>
+          <p:cNvPr id="30" name="Rounded Rectangle 29"/>
           <p:cNvSpPr/>
           <p:nvPr/>
         </p:nvSpPr>
@@ -10615,7 +10688,7 @@
       </p:sp>
       <p:sp>
         <p:nvSpPr>
-          <p:cNvPr id="30" name="Rounded Rectangle 29"/>
+          <p:cNvPr id="31" name="Rounded Rectangle 30"/>
           <p:cNvSpPr/>
           <p:nvPr/>
         </p:nvSpPr>
@@ -10672,7 +10745,7 @@
       </p:sp>
       <p:sp>
         <p:nvSpPr>
-          <p:cNvPr id="31" name="Rounded Rectangle 30">
+          <p:cNvPr id="32" name="Rounded Rectangle 31">
             <a:hlinkClick action="ppaction://hlinksldjump" r:id="rId3"/>
           </p:cNvPr>
           <p:cNvSpPr/>
@@ -10731,7 +10804,7 @@
       </p:sp>
       <p:sp>
         <p:nvSpPr>
-          <p:cNvPr id="32" name="TextBox 31"/>
+          <p:cNvPr id="33" name="TextBox 32"/>
           <p:cNvSpPr txBox="1"/>
           <p:nvPr/>
         </p:nvSpPr>
@@ -10776,7 +10849,7 @@
       </p:sp>
       <p:sp>
         <p:nvSpPr>
-          <p:cNvPr id="33" name="Rounded Rectangle 32"/>
+          <p:cNvPr id="34" name="Rounded Rectangle 33"/>
           <p:cNvSpPr/>
           <p:nvPr/>
         </p:nvSpPr>
@@ -10852,7 +10925,7 @@
       </p:sp>
       <p:sp>
         <p:nvSpPr>
-          <p:cNvPr id="34" name="Rounded Rectangle 33"/>
+          <p:cNvPr id="35" name="Rounded Rectangle 34"/>
           <p:cNvSpPr/>
           <p:nvPr/>
         </p:nvSpPr>
@@ -10907,7 +10980,7 @@
       </p:sp>
       <p:sp>
         <p:nvSpPr>
-          <p:cNvPr id="35" name="Rectangle 34"/>
+          <p:cNvPr id="36" name="Rectangle 35"/>
           <p:cNvSpPr/>
           <p:nvPr/>
         </p:nvSpPr>
@@ -10951,7 +11024,7 @@
       </p:sp>
       <p:sp>
         <p:nvSpPr>
-          <p:cNvPr id="36" name="TextBox 35"/>
+          <p:cNvPr id="37" name="TextBox 36"/>
           <p:cNvSpPr txBox="1"/>
           <p:nvPr/>
         </p:nvSpPr>
@@ -11005,7 +11078,7 @@
       </p:sp>
       <p:sp>
         <p:nvSpPr>
-          <p:cNvPr id="37" name="TextBox 36"/>
+          <p:cNvPr id="38" name="TextBox 37"/>
           <p:cNvSpPr txBox="1"/>
           <p:nvPr/>
         </p:nvSpPr>
@@ -11050,7 +11123,7 @@
       </p:sp>
       <p:sp>
         <p:nvSpPr>
-          <p:cNvPr id="38" name="TextBox 37"/>
+          <p:cNvPr id="39" name="TextBox 38"/>
           <p:cNvSpPr txBox="1"/>
           <p:nvPr/>
         </p:nvSpPr>
@@ -11132,7 +11205,7 @@
                                           </p:stCondLst>
                                         </p:cTn>
                                         <p:tgtEl>
-                                          <p:spTgt spid="33"/>
+                                          <p:spTgt spid="34"/>
                                         </p:tgtEl>
                                         <p:attrNameLst>
                                           <p:attrName>style.visibility</p:attrName>
@@ -11146,7 +11219,7 @@
                                       <p:cBhvr>
                                         <p:cTn id="7" dur="500"/>
                                         <p:tgtEl>
-                                          <p:spTgt spid="33"/>
+                                          <p:spTgt spid="34"/>
                                         </p:tgtEl>
                                       </p:cBhvr>
                                     </p:animEffect>
@@ -11185,7 +11258,7 @@
                                           </p:stCondLst>
                                         </p:cTn>
                                         <p:tgtEl>
-                                          <p:spTgt spid="34"/>
+                                          <p:spTgt spid="35"/>
                                         </p:tgtEl>
                                         <p:attrNameLst>
                                           <p:attrName>style.visibility</p:attrName>
@@ -11199,7 +11272,7 @@
                                       <p:cBhvr>
                                         <p:cTn id="12" dur="500"/>
                                         <p:tgtEl>
-                                          <p:spTgt spid="34"/>
+                                          <p:spTgt spid="35"/>
                                         </p:tgtEl>
                                       </p:cBhvr>
                                     </p:animEffect>

</xml_diff>